<commit_message>
docs: add GitHub repo link to first page of presentation and documentation PDF
</commit_message>
<xml_diff>
--- a/Documentation/BuzzFly_Web_Presentation.pptx
+++ b/Documentation/BuzzFly_Web_Presentation.pptx
@@ -3312,6 +3312,50 @@
                 <a:latin typeface="Segoe UI"/>
               </a:rPr>
               <a:t>June 2026</a:t>
+            </a:r>
+          </a:p>
+        </p:txBody>
+      </p:sp>
+      <p:sp>
+        <p:nvSpPr>
+          <p:cNvPr id="8" name="TextBox 7"/>
+          <p:cNvSpPr txBox="1"/>
+          <p:nvPr/>
+        </p:nvSpPr>
+        <p:spPr>
+          <a:xfrm>
+            <a:off x="502920" y="5715000"/>
+            <a:ext cx="10972800" cy="365760"/>
+          </a:xfrm>
+          <a:prstGeom prst="rect">
+            <a:avLst/>
+          </a:prstGeom>
+          <a:noFill/>
+        </p:spPr>
+        <p:txBody>
+          <a:bodyPr wrap="square">
+            <a:spAutoFit/>
+          </a:bodyPr>
+          <a:lstStyle/>
+          <a:p>
+            <a:r>
+              <a:rPr sz="1200">
+                <a:solidFill>
+                  <a:srgbClr val="6C757D"/>
+                </a:solidFill>
+                <a:latin typeface="Segoe UI"/>
+              </a:rPr>
+              <a:t>GitHub repo: </a:t>
+            </a:r>
+            <a:r>
+              <a:rPr sz="1200" b="1">
+                <a:solidFill>
+                  <a:srgbClr val="632CE5"/>
+                </a:solidFill>
+                <a:latin typeface="Segoe UI"/>
+                <a:hlinkClick r:id="rId2"/>
+              </a:rPr>
+              <a:t>https://github.com/Karimkimoz74/buzz-fly</a:t>
             </a:r>
           </a:p>
         </p:txBody>

</xml_diff>

<commit_message>
docs: update web presentation pptx with manual edits
</commit_message>
<xml_diff>
--- a/Documentation/BuzzFly_Web_Presentation.pptx
+++ b/Documentation/BuzzFly_Web_Presentation.pptx
@@ -313,7 +313,7 @@
           <a:p>
             <a:fld id="{5BCAD085-E8A6-8845-BD4E-CB4CCA059FC4}" type="datetimeFigureOut">
               <a:rPr lang="en-US" smtClean="0"/>
-              <a:t>6/1/2026</a:t>
+              <a:t>6/2/2026</a:t>
             </a:fld>
             <a:endParaRPr lang="en-US"/>
           </a:p>
@@ -481,7 +481,7 @@
           <a:p>
             <a:fld id="{5BCAD085-E8A6-8845-BD4E-CB4CCA059FC4}" type="datetimeFigureOut">
               <a:rPr lang="en-US" smtClean="0"/>
-              <a:t>6/1/2026</a:t>
+              <a:t>6/2/2026</a:t>
             </a:fld>
             <a:endParaRPr lang="en-US"/>
           </a:p>
@@ -659,7 +659,7 @@
           <a:p>
             <a:fld id="{5BCAD085-E8A6-8845-BD4E-CB4CCA059FC4}" type="datetimeFigureOut">
               <a:rPr lang="en-US" smtClean="0"/>
-              <a:t>6/1/2026</a:t>
+              <a:t>6/2/2026</a:t>
             </a:fld>
             <a:endParaRPr lang="en-US"/>
           </a:p>
@@ -827,7 +827,7 @@
           <a:p>
             <a:fld id="{5BCAD085-E8A6-8845-BD4E-CB4CCA059FC4}" type="datetimeFigureOut">
               <a:rPr lang="en-US" smtClean="0"/>
-              <a:t>6/1/2026</a:t>
+              <a:t>6/2/2026</a:t>
             </a:fld>
             <a:endParaRPr lang="en-US"/>
           </a:p>
@@ -1072,7 +1072,7 @@
           <a:p>
             <a:fld id="{5BCAD085-E8A6-8845-BD4E-CB4CCA059FC4}" type="datetimeFigureOut">
               <a:rPr lang="en-US" smtClean="0"/>
-              <a:t>6/1/2026</a:t>
+              <a:t>6/2/2026</a:t>
             </a:fld>
             <a:endParaRPr lang="en-US"/>
           </a:p>
@@ -1357,7 +1357,7 @@
           <a:p>
             <a:fld id="{5BCAD085-E8A6-8845-BD4E-CB4CCA059FC4}" type="datetimeFigureOut">
               <a:rPr lang="en-US" smtClean="0"/>
-              <a:t>6/1/2026</a:t>
+              <a:t>6/2/2026</a:t>
             </a:fld>
             <a:endParaRPr lang="en-US"/>
           </a:p>
@@ -1776,7 +1776,7 @@
           <a:p>
             <a:fld id="{5BCAD085-E8A6-8845-BD4E-CB4CCA059FC4}" type="datetimeFigureOut">
               <a:rPr lang="en-US" smtClean="0"/>
-              <a:t>6/1/2026</a:t>
+              <a:t>6/2/2026</a:t>
             </a:fld>
             <a:endParaRPr lang="en-US"/>
           </a:p>
@@ -1893,7 +1893,7 @@
           <a:p>
             <a:fld id="{5BCAD085-E8A6-8845-BD4E-CB4CCA059FC4}" type="datetimeFigureOut">
               <a:rPr lang="en-US" smtClean="0"/>
-              <a:t>6/1/2026</a:t>
+              <a:t>6/2/2026</a:t>
             </a:fld>
             <a:endParaRPr lang="en-US"/>
           </a:p>
@@ -1988,7 +1988,7 @@
           <a:p>
             <a:fld id="{5BCAD085-E8A6-8845-BD4E-CB4CCA059FC4}" type="datetimeFigureOut">
               <a:rPr lang="en-US" smtClean="0"/>
-              <a:t>6/1/2026</a:t>
+              <a:t>6/2/2026</a:t>
             </a:fld>
             <a:endParaRPr lang="en-US"/>
           </a:p>
@@ -2263,7 +2263,7 @@
           <a:p>
             <a:fld id="{5BCAD085-E8A6-8845-BD4E-CB4CCA059FC4}" type="datetimeFigureOut">
               <a:rPr lang="en-US" smtClean="0"/>
-              <a:t>6/1/2026</a:t>
+              <a:t>6/2/2026</a:t>
             </a:fld>
             <a:endParaRPr lang="en-US"/>
           </a:p>
@@ -2515,7 +2515,7 @@
           <a:p>
             <a:fld id="{5BCAD085-E8A6-8845-BD4E-CB4CCA059FC4}" type="datetimeFigureOut">
               <a:rPr lang="en-US" smtClean="0"/>
-              <a:t>6/1/2026</a:t>
+              <a:t>6/2/2026</a:t>
             </a:fld>
             <a:endParaRPr lang="en-US"/>
           </a:p>
@@ -2726,7 +2726,7 @@
           <a:p>
             <a:fld id="{5BCAD085-E8A6-8845-BD4E-CB4CCA059FC4}" type="datetimeFigureOut">
               <a:rPr lang="en-US" smtClean="0"/>
-              <a:t>6/1/2026</a:t>
+              <a:t>6/2/2026</a:t>
             </a:fld>
             <a:endParaRPr lang="en-US"/>
           </a:p>
@@ -3257,7 +3257,7 @@
         <p:spPr>
           <a:xfrm>
             <a:off x="502920" y="5989320"/>
-            <a:ext cx="10972800" cy="365760"/>
+            <a:ext cx="10972800" cy="221599"/>
           </a:xfrm>
           <a:prstGeom prst="rect">
             <a:avLst/>
@@ -3277,7 +3277,16 @@
                 </a:solidFill>
                 <a:latin typeface="Segoe UI"/>
               </a:rPr>
-              <a:t>Group 15    Web Engineering    Semester 8</a:t>
+              <a:t>Web </a:t>
+            </a:r>
+            <a:r>
+              <a:rPr sz="1200" b="0" dirty="0">
+                <a:solidFill>
+                  <a:srgbClr val="6C757D"/>
+                </a:solidFill>
+                <a:latin typeface="Segoe UI"/>
+              </a:rPr>
+              <a:t>Engineering    Semester 8</a:t>
             </a:r>
           </a:p>
         </p:txBody>

</xml_diff>